<commit_message>
Update 연상 게임 assets and add ZIP slides
Co-Authored-By: Claude Opus 4.6 (1M context) <noreply@anthropic.com>
</commit_message>
<xml_diff>
--- a/public/downloads/games/word-association/rules.pptx
+++ b/public/downloads/games/word-association/rules.pptx
@@ -24,16 +24,8 @@
   <p:notesSz cx="6858000" cy="9144000"/>
   <p:embeddedFontLst>
     <p:embeddedFont>
-      <p:font typeface="Jua" charset="1" panose="00000000000000000000"/>
+      <p:font typeface="무궁화 고딕" charset="1" panose="02020603020101020101"/>
       <p:regular r:id="rId20"/>
-    </p:embeddedFont>
-    <p:embeddedFont>
-      <p:font typeface="TDTD갬성명조" charset="1" panose="02000503000000000000"/>
-      <p:regular r:id="rId21"/>
-    </p:embeddedFont>
-    <p:embeddedFont>
-      <p:font typeface="TDTD가온" charset="1" panose="02000503000000000000"/>
-      <p:regular r:id="rId22"/>
     </p:embeddedFont>
   </p:embeddedFontLst>
   <p:defaultTextStyle>
@@ -3151,8 +3143,8 @@
         </p:nvSpPr>
         <p:spPr>
           <a:xfrm rot="0">
-            <a:off x="1028700" y="3892867"/>
-            <a:ext cx="15555091" cy="2200275"/>
+            <a:off x="1028700" y="4178617"/>
+            <a:ext cx="15555091" cy="1914525"/>
           </a:xfrm>
           <a:prstGeom prst="rect">
             <a:avLst/>
@@ -3174,10 +3166,10 @@
                 <a:solidFill>
                   <a:srgbClr val="FFFAEF"/>
                 </a:solidFill>
-                <a:latin typeface="Jua"/>
-                <a:ea typeface="Jua"/>
-                <a:cs typeface="Jua"/>
-                <a:sym typeface="Jua"/>
+                <a:latin typeface="무궁화 고딕"/>
+                <a:ea typeface="무궁화 고딕"/>
+                <a:cs typeface="무궁화 고딕"/>
+                <a:sym typeface="무궁화 고딕"/>
               </a:rPr>
               <a:t>연상 게임</a:t>
             </a:r>
@@ -3192,8 +3184,8 @@
         </p:nvSpPr>
         <p:spPr>
           <a:xfrm rot="0">
-            <a:off x="15264803" y="9812655"/>
-            <a:ext cx="2637975" cy="474345"/>
+            <a:off x="14562961" y="9822180"/>
+            <a:ext cx="3339817" cy="464820"/>
           </a:xfrm>
           <a:prstGeom prst="rect">
             <a:avLst/>
@@ -3218,10 +3210,10 @@
                 <a:solidFill>
                   <a:srgbClr val="FFFFFF"/>
                 </a:solidFill>
-                <a:latin typeface="TDTD갬성명조"/>
-                <a:ea typeface="TDTD갬성명조"/>
-                <a:cs typeface="TDTD갬성명조"/>
-                <a:sym typeface="TDTD갬성명조"/>
+                <a:latin typeface="무궁화 고딕"/>
+                <a:ea typeface="무궁화 고딕"/>
+                <a:cs typeface="무궁화 고딕"/>
+                <a:sym typeface="무궁화 고딕"/>
               </a:rPr>
               <a:t>ⓒ 2026. Sunday Play</a:t>
             </a:r>
@@ -3268,8 +3260,8 @@
         </p:nvSpPr>
         <p:spPr>
           <a:xfrm rot="0">
-            <a:off x="3238925" y="3349845"/>
-            <a:ext cx="11810151" cy="3514725"/>
+            <a:off x="3238925" y="3807045"/>
+            <a:ext cx="11810151" cy="3057525"/>
           </a:xfrm>
           <a:prstGeom prst="rect">
             <a:avLst/>
@@ -3291,10 +3283,10 @@
                 <a:solidFill>
                   <a:srgbClr val="000000"/>
                 </a:solidFill>
-                <a:latin typeface="Jua"/>
-                <a:ea typeface="Jua"/>
-                <a:cs typeface="Jua"/>
-                <a:sym typeface="Jua"/>
+                <a:latin typeface="무궁화 고딕"/>
+                <a:ea typeface="무궁화 고딕"/>
+                <a:cs typeface="무궁화 고딕"/>
+                <a:sym typeface="무궁화 고딕"/>
               </a:rPr>
               <a:t>연인</a:t>
             </a:r>
@@ -3391,8 +3383,8 @@
         </p:nvSpPr>
         <p:spPr>
           <a:xfrm rot="0">
-            <a:off x="3238925" y="3349845"/>
-            <a:ext cx="11810151" cy="3514725"/>
+            <a:off x="3238925" y="3807045"/>
+            <a:ext cx="11810151" cy="3057525"/>
           </a:xfrm>
           <a:prstGeom prst="rect">
             <a:avLst/>
@@ -3414,10 +3406,10 @@
                 <a:solidFill>
                   <a:srgbClr val="000000"/>
                 </a:solidFill>
-                <a:latin typeface="Jua"/>
-                <a:ea typeface="Jua"/>
-                <a:cs typeface="Jua"/>
-                <a:sym typeface="Jua"/>
+                <a:latin typeface="무궁화 고딕"/>
+                <a:ea typeface="무궁화 고딕"/>
+                <a:cs typeface="무궁화 고딕"/>
+                <a:sym typeface="무궁화 고딕"/>
               </a:rPr>
               <a:t>친구</a:t>
             </a:r>
@@ -3514,8 +3506,8 @@
         </p:nvSpPr>
         <p:spPr>
           <a:xfrm rot="0">
-            <a:off x="3238925" y="3349845"/>
-            <a:ext cx="11810151" cy="3514725"/>
+            <a:off x="3238925" y="3807045"/>
+            <a:ext cx="11810151" cy="3057525"/>
           </a:xfrm>
           <a:prstGeom prst="rect">
             <a:avLst/>
@@ -3537,10 +3529,10 @@
                 <a:solidFill>
                   <a:srgbClr val="000000"/>
                 </a:solidFill>
-                <a:latin typeface="Jua"/>
-                <a:ea typeface="Jua"/>
-                <a:cs typeface="Jua"/>
-                <a:sym typeface="Jua"/>
+                <a:latin typeface="무궁화 고딕"/>
+                <a:ea typeface="무궁화 고딕"/>
+                <a:cs typeface="무궁화 고딕"/>
+                <a:sym typeface="무궁화 고딕"/>
               </a:rPr>
               <a:t>밤</a:t>
             </a:r>
@@ -3637,8 +3629,8 @@
         </p:nvSpPr>
         <p:spPr>
           <a:xfrm rot="0">
-            <a:off x="3238925" y="3349845"/>
-            <a:ext cx="11810151" cy="3514725"/>
+            <a:off x="3238925" y="3807045"/>
+            <a:ext cx="11810151" cy="3057525"/>
           </a:xfrm>
           <a:prstGeom prst="rect">
             <a:avLst/>
@@ -3660,10 +3652,10 @@
                 <a:solidFill>
                   <a:srgbClr val="000000"/>
                 </a:solidFill>
-                <a:latin typeface="Jua"/>
-                <a:ea typeface="Jua"/>
-                <a:cs typeface="Jua"/>
-                <a:sym typeface="Jua"/>
+                <a:latin typeface="무궁화 고딕"/>
+                <a:ea typeface="무궁화 고딕"/>
+                <a:cs typeface="무궁화 고딕"/>
+                <a:sym typeface="무궁화 고딕"/>
               </a:rPr>
               <a:t>똥</a:t>
             </a:r>
@@ -3785,8 +3777,8 @@
         </p:nvSpPr>
         <p:spPr>
           <a:xfrm rot="0">
-            <a:off x="4421807" y="3895725"/>
-            <a:ext cx="9444385" cy="2200275"/>
+            <a:off x="4421807" y="4181475"/>
+            <a:ext cx="9444385" cy="1914525"/>
           </a:xfrm>
           <a:prstGeom prst="rect">
             <a:avLst/>
@@ -3808,10 +3800,10 @@
                 <a:solidFill>
                   <a:srgbClr val="000000"/>
                 </a:solidFill>
-                <a:latin typeface="Jua"/>
-                <a:ea typeface="Jua"/>
-                <a:cs typeface="Jua"/>
-                <a:sym typeface="Jua"/>
+                <a:latin typeface="무궁화 고딕"/>
+                <a:ea typeface="무궁화 고딕"/>
+                <a:cs typeface="무궁화 고딕"/>
+                <a:sym typeface="무궁화 고딕"/>
               </a:rPr>
               <a:t>감사합니다!</a:t>
             </a:r>
@@ -4010,8 +4002,8 @@
         </p:nvSpPr>
         <p:spPr>
           <a:xfrm rot="0">
-            <a:off x="11392761" y="600705"/>
-            <a:ext cx="5362043" cy="1600200"/>
+            <a:off x="11392761" y="819780"/>
+            <a:ext cx="5362043" cy="1381125"/>
           </a:xfrm>
           <a:prstGeom prst="rect">
             <a:avLst/>
@@ -4033,10 +4025,10 @@
                 <a:solidFill>
                   <a:srgbClr val="FFFAEF"/>
                 </a:solidFill>
-                <a:latin typeface="Jua"/>
-                <a:ea typeface="Jua"/>
-                <a:cs typeface="Jua"/>
-                <a:sym typeface="Jua"/>
+                <a:latin typeface="무궁화 고딕"/>
+                <a:ea typeface="무궁화 고딕"/>
+                <a:cs typeface="무궁화 고딕"/>
+                <a:sym typeface="무궁화 고딕"/>
               </a:rPr>
               <a:t>규칙</a:t>
             </a:r>
@@ -4052,9 +4044,9 @@
         <p:grpSpPr>
           <a:xfrm rot="0">
             <a:off x="309172" y="535073"/>
-            <a:ext cx="12078314" cy="1779769"/>
+            <a:ext cx="12078314" cy="1702981"/>
             <a:chOff x="0" y="0"/>
-            <a:chExt cx="16104419" cy="2373026"/>
+            <a:chExt cx="16104419" cy="2270642"/>
           </a:xfrm>
         </p:grpSpPr>
         <p:sp>
@@ -4065,8 +4057,8 @@
           </p:nvSpPr>
           <p:spPr>
             <a:xfrm rot="0">
-              <a:off x="0" y="1380584"/>
-              <a:ext cx="16104419" cy="992442"/>
+              <a:off x="0" y="1390109"/>
+              <a:ext cx="16104419" cy="880533"/>
             </a:xfrm>
             <a:prstGeom prst="rect">
               <a:avLst/>
@@ -4080,30 +4072,30 @@
             <a:p>
               <a:pPr algn="l">
                 <a:lnSpc>
-                  <a:spcPts val="6273"/>
+                  <a:spcPts val="5599"/>
                 </a:lnSpc>
               </a:pPr>
               <a:r>
-                <a:rPr lang="en-US" sz="4480">
+                <a:rPr lang="en-US" sz="3999">
                   <a:solidFill>
                     <a:srgbClr val="FFFAEF"/>
                   </a:solidFill>
-                  <a:latin typeface="TDTD가온"/>
-                  <a:ea typeface="TDTD가온"/>
-                  <a:cs typeface="TDTD가온"/>
-                  <a:sym typeface="TDTD가온"/>
+                  <a:latin typeface="무궁화 고딕"/>
+                  <a:ea typeface="무궁화 고딕"/>
+                  <a:cs typeface="무궁화 고딕"/>
+                  <a:sym typeface="무궁화 고딕"/>
                 </a:rPr>
                 <a:t>원형으로 앉습니다. 진행자가 첫 단어를</a:t>
               </a:r>
               <a:r>
-                <a:rPr lang="en-US" sz="4480">
+                <a:rPr lang="en-US" sz="3999">
                   <a:solidFill>
                     <a:srgbClr val="FFFAEF"/>
                   </a:solidFill>
-                  <a:latin typeface="TDTD가온"/>
-                  <a:ea typeface="TDTD가온"/>
-                  <a:cs typeface="TDTD가온"/>
-                  <a:sym typeface="TDTD가온"/>
+                  <a:latin typeface="무궁화 고딕"/>
+                  <a:ea typeface="무궁화 고딕"/>
+                  <a:cs typeface="무궁화 고딕"/>
+                  <a:sym typeface="무궁화 고딕"/>
                 </a:rPr>
                 <a:t> 말합니다.</a:t>
               </a:r>
@@ -4118,8 +4110,8 @@
           </p:nvSpPr>
           <p:spPr>
             <a:xfrm rot="0">
-              <a:off x="0" y="-171450"/>
-              <a:ext cx="9574913" cy="1169217"/>
+              <a:off x="0" y="-66675"/>
+              <a:ext cx="9574913" cy="1064442"/>
             </a:xfrm>
             <a:prstGeom prst="rect">
               <a:avLst/>
@@ -4141,10 +4133,10 @@
                   <a:solidFill>
                     <a:srgbClr val="FFFAEF"/>
                   </a:solidFill>
-                  <a:latin typeface="Jua"/>
-                  <a:ea typeface="Jua"/>
-                  <a:cs typeface="Jua"/>
-                  <a:sym typeface="Jua"/>
+                  <a:latin typeface="무궁화 고딕"/>
+                  <a:ea typeface="무궁화 고딕"/>
+                  <a:cs typeface="무궁화 고딕"/>
+                  <a:sym typeface="무궁화 고딕"/>
                 </a:rPr>
                 <a:t>STEP 1.</a:t>
               </a:r>
@@ -4161,9 +4153,9 @@
         <p:grpSpPr>
           <a:xfrm rot="0">
             <a:off x="10161695" y="7503133"/>
-            <a:ext cx="7731536" cy="2574122"/>
+            <a:ext cx="7731536" cy="2405544"/>
             <a:chOff x="0" y="0"/>
-            <a:chExt cx="10308715" cy="3432162"/>
+            <a:chExt cx="10308715" cy="3207392"/>
           </a:xfrm>
         </p:grpSpPr>
         <p:sp>
@@ -4175,7 +4167,7 @@
           <p:spPr>
             <a:xfrm rot="0">
               <a:off x="0" y="1377534"/>
-              <a:ext cx="10151114" cy="2054628"/>
+              <a:ext cx="10151114" cy="1829858"/>
             </a:xfrm>
             <a:prstGeom prst="rect">
               <a:avLst/>
@@ -4189,30 +4181,30 @@
             <a:p>
               <a:pPr algn="l">
                 <a:lnSpc>
-                  <a:spcPts val="6284"/>
+                  <a:spcPts val="5600"/>
                 </a:lnSpc>
               </a:pPr>
               <a:r>
-                <a:rPr lang="en-US" sz="4489">
+                <a:rPr lang="en-US" sz="4000">
                   <a:solidFill>
                     <a:srgbClr val="FFFAEF"/>
                   </a:solidFill>
-                  <a:latin typeface="TDTD가온"/>
-                  <a:ea typeface="TDTD가온"/>
-                  <a:cs typeface="TDTD가온"/>
-                  <a:sym typeface="TDTD가온"/>
+                  <a:latin typeface="무궁화 고딕"/>
+                  <a:ea typeface="무궁화 고딕"/>
+                  <a:cs typeface="무궁화 고딕"/>
+                  <a:sym typeface="무궁화 고딕"/>
                 </a:rPr>
                 <a:t>5초 초과 또는</a:t>
               </a:r>
               <a:r>
-                <a:rPr lang="en-US" sz="4489">
+                <a:rPr lang="en-US" sz="4000">
                   <a:solidFill>
                     <a:srgbClr val="FFFAEF"/>
                   </a:solidFill>
-                  <a:latin typeface="TDTD가온"/>
-                  <a:ea typeface="TDTD가온"/>
-                  <a:cs typeface="TDTD가온"/>
-                  <a:sym typeface="TDTD가온"/>
+                  <a:latin typeface="무궁화 고딕"/>
+                  <a:ea typeface="무궁화 고딕"/>
+                  <a:cs typeface="무궁화 고딕"/>
+                  <a:sym typeface="무궁화 고딕"/>
                 </a:rPr>
                 <a:t> 연관 없는 단어 = 탈락!            </a:t>
               </a:r>
@@ -4220,18 +4212,18 @@
             <a:p>
               <a:pPr algn="l">
                 <a:lnSpc>
-                  <a:spcPts val="6284"/>
+                  <a:spcPts val="5600"/>
                 </a:lnSpc>
               </a:pPr>
               <a:r>
-                <a:rPr lang="en-US" sz="4489">
+                <a:rPr lang="en-US" sz="4000">
                   <a:solidFill>
                     <a:srgbClr val="FFFAEF"/>
                   </a:solidFill>
-                  <a:latin typeface="TDTD가온"/>
-                  <a:ea typeface="TDTD가온"/>
-                  <a:cs typeface="TDTD가온"/>
-                  <a:sym typeface="TDTD가온"/>
+                  <a:latin typeface="무궁화 고딕"/>
+                  <a:ea typeface="무궁화 고딕"/>
+                  <a:cs typeface="무궁화 고딕"/>
+                  <a:sym typeface="무궁화 고딕"/>
                 </a:rPr>
                 <a:t>최후의 1인이 우승!</a:t>
               </a:r>
@@ -4246,8 +4238,8 @@
           </p:nvSpPr>
           <p:spPr>
             <a:xfrm rot="0">
-              <a:off x="0" y="-171450"/>
-              <a:ext cx="10308715" cy="1171105"/>
+              <a:off x="0" y="-57150"/>
+              <a:ext cx="10308715" cy="1056805"/>
             </a:xfrm>
             <a:prstGeom prst="rect">
               <a:avLst/>
@@ -4269,10 +4261,10 @@
                   <a:solidFill>
                     <a:srgbClr val="FFFAEF"/>
                   </a:solidFill>
-                  <a:latin typeface="Jua"/>
-                  <a:ea typeface="Jua"/>
-                  <a:cs typeface="Jua"/>
-                  <a:sym typeface="Jua"/>
+                  <a:latin typeface="무궁화 고딕"/>
+                  <a:ea typeface="무궁화 고딕"/>
+                  <a:cs typeface="무궁화 고딕"/>
+                  <a:sym typeface="무궁화 고딕"/>
                 </a:rPr>
                 <a:t>STEP 3.</a:t>
               </a:r>
@@ -4288,10 +4280,10 @@
         </p:nvGrpSpPr>
         <p:grpSpPr>
           <a:xfrm rot="0">
-            <a:off x="4160494" y="3261405"/>
-            <a:ext cx="9394998" cy="3364141"/>
+            <a:off x="4446501" y="3316265"/>
+            <a:ext cx="9394998" cy="3108657"/>
             <a:chOff x="0" y="0"/>
-            <a:chExt cx="12526665" cy="4485521"/>
+            <a:chExt cx="12526665" cy="4144876"/>
           </a:xfrm>
         </p:grpSpPr>
         <p:sp>
@@ -4302,8 +4294,8 @@
           </p:nvSpPr>
           <p:spPr>
             <a:xfrm rot="0">
-              <a:off x="0" y="1375218"/>
-              <a:ext cx="12526665" cy="3110303"/>
+              <a:off x="0" y="1384743"/>
+              <a:ext cx="12526665" cy="2760133"/>
             </a:xfrm>
             <a:prstGeom prst="rect">
               <a:avLst/>
@@ -4317,18 +4309,18 @@
             <a:p>
               <a:pPr algn="l">
                 <a:lnSpc>
-                  <a:spcPts val="6275"/>
+                  <a:spcPts val="5599"/>
                 </a:lnSpc>
               </a:pPr>
               <a:r>
-                <a:rPr lang="en-US" sz="4482">
+                <a:rPr lang="en-US" sz="3999">
                   <a:solidFill>
                     <a:srgbClr val="FFFAEF"/>
                   </a:solidFill>
-                  <a:latin typeface="TDTD가온"/>
-                  <a:ea typeface="TDTD가온"/>
-                  <a:cs typeface="TDTD가온"/>
-                  <a:sym typeface="TDTD가온"/>
+                  <a:latin typeface="무궁화 고딕"/>
+                  <a:ea typeface="무궁화 고딕"/>
+                  <a:cs typeface="무궁화 고딕"/>
+                  <a:sym typeface="무궁화 고딕"/>
                 </a:rPr>
                 <a:t>오른쪽으로 돌아가며 이전 단어와</a:t>
               </a:r>
@@ -4336,18 +4328,18 @@
             <a:p>
               <a:pPr algn="l">
                 <a:lnSpc>
-                  <a:spcPts val="6275"/>
+                  <a:spcPts val="5599"/>
                 </a:lnSpc>
               </a:pPr>
               <a:r>
-                <a:rPr lang="en-US" sz="4482">
+                <a:rPr lang="en-US" sz="3999">
                   <a:solidFill>
                     <a:srgbClr val="FFFAEF"/>
                   </a:solidFill>
-                  <a:latin typeface="TDTD가온"/>
-                  <a:ea typeface="TDTD가온"/>
-                  <a:cs typeface="TDTD가온"/>
-                  <a:sym typeface="TDTD가온"/>
+                  <a:latin typeface="무궁화 고딕"/>
+                  <a:ea typeface="무궁화 고딕"/>
+                  <a:cs typeface="무궁화 고딕"/>
+                  <a:sym typeface="무궁화 고딕"/>
                 </a:rPr>
                 <a:t>연관된 단어를 5초 안에 말합니다.</a:t>
               </a:r>
@@ -4355,18 +4347,18 @@
             <a:p>
               <a:pPr algn="l">
                 <a:lnSpc>
-                  <a:spcPts val="6275"/>
+                  <a:spcPts val="5599"/>
                 </a:lnSpc>
               </a:pPr>
               <a:r>
-                <a:rPr lang="en-US" sz="4482">
+                <a:rPr lang="en-US" sz="3999">
                   <a:solidFill>
                     <a:srgbClr val="FFFAEF"/>
                   </a:solidFill>
-                  <a:latin typeface="TDTD가온"/>
-                  <a:ea typeface="TDTD가온"/>
-                  <a:cs typeface="TDTD가온"/>
-                  <a:sym typeface="TDTD가온"/>
+                  <a:latin typeface="무궁화 고딕"/>
+                  <a:ea typeface="무궁화 고딕"/>
+                  <a:cs typeface="무궁화 고딕"/>
+                  <a:sym typeface="무궁화 고딕"/>
                 </a:rPr>
                 <a:t>(예: 고양이 → 방울 → 소 → 쟁기 → 농사꾼)</a:t>
               </a:r>
@@ -4381,8 +4373,8 @@
           </p:nvSpPr>
           <p:spPr>
             <a:xfrm rot="0">
-              <a:off x="0" y="-171450"/>
-              <a:ext cx="6898637" cy="1169523"/>
+              <a:off x="0" y="-57150"/>
+              <a:ext cx="6898637" cy="1055223"/>
             </a:xfrm>
             <a:prstGeom prst="rect">
               <a:avLst/>
@@ -4404,10 +4396,10 @@
                   <a:solidFill>
                     <a:srgbClr val="FFFAEF"/>
                   </a:solidFill>
-                  <a:latin typeface="Jua"/>
-                  <a:ea typeface="Jua"/>
-                  <a:cs typeface="Jua"/>
-                  <a:sym typeface="Jua"/>
+                  <a:latin typeface="무궁화 고딕"/>
+                  <a:ea typeface="무궁화 고딕"/>
+                  <a:cs typeface="무궁화 고딕"/>
+                  <a:sym typeface="무궁화 고딕"/>
                 </a:rPr>
                 <a:t>STEP 2.</a:t>
               </a:r>
@@ -4505,8 +4497,8 @@
         </p:nvSpPr>
         <p:spPr>
           <a:xfrm rot="0">
-            <a:off x="1028700" y="3892867"/>
-            <a:ext cx="15555091" cy="2200275"/>
+            <a:off x="1028700" y="4178617"/>
+            <a:ext cx="15555091" cy="1914525"/>
           </a:xfrm>
           <a:prstGeom prst="rect">
             <a:avLst/>
@@ -4528,10 +4520,10 @@
                 <a:solidFill>
                   <a:srgbClr val="FFFAEF"/>
                 </a:solidFill>
-                <a:latin typeface="Jua"/>
-                <a:ea typeface="Jua"/>
-                <a:cs typeface="Jua"/>
-                <a:sym typeface="Jua"/>
+                <a:latin typeface="무궁화 고딕"/>
+                <a:ea typeface="무궁화 고딕"/>
+                <a:cs typeface="무궁화 고딕"/>
+                <a:sym typeface="무궁화 고딕"/>
               </a:rPr>
               <a:t>연상 게임</a:t>
             </a:r>
@@ -4546,8 +4538,8 @@
         </p:nvSpPr>
         <p:spPr>
           <a:xfrm rot="0">
-            <a:off x="15264803" y="9812655"/>
-            <a:ext cx="2637975" cy="474345"/>
+            <a:off x="14562961" y="9822180"/>
+            <a:ext cx="3339817" cy="464820"/>
           </a:xfrm>
           <a:prstGeom prst="rect">
             <a:avLst/>
@@ -4572,10 +4564,10 @@
                 <a:solidFill>
                   <a:srgbClr val="FFFFFF"/>
                 </a:solidFill>
-                <a:latin typeface="TDTD갬성명조"/>
-                <a:ea typeface="TDTD갬성명조"/>
-                <a:cs typeface="TDTD갬성명조"/>
-                <a:sym typeface="TDTD갬성명조"/>
+                <a:latin typeface="무궁화 고딕"/>
+                <a:ea typeface="무궁화 고딕"/>
+                <a:cs typeface="무궁화 고딕"/>
+                <a:sym typeface="무궁화 고딕"/>
               </a:rPr>
               <a:t>ⓒ 2026. Sunday Play</a:t>
             </a:r>
@@ -4622,8 +4614,8 @@
         </p:nvSpPr>
         <p:spPr>
           <a:xfrm rot="0">
-            <a:off x="3238925" y="3349845"/>
-            <a:ext cx="11810151" cy="3514725"/>
+            <a:off x="3238925" y="3807045"/>
+            <a:ext cx="11810151" cy="3057525"/>
           </a:xfrm>
           <a:prstGeom prst="rect">
             <a:avLst/>
@@ -4645,10 +4637,10 @@
                 <a:solidFill>
                   <a:srgbClr val="000000"/>
                 </a:solidFill>
-                <a:latin typeface="Jua"/>
-                <a:ea typeface="Jua"/>
-                <a:cs typeface="Jua"/>
-                <a:sym typeface="Jua"/>
+                <a:latin typeface="무궁화 고딕"/>
+                <a:ea typeface="무궁화 고딕"/>
+                <a:cs typeface="무궁화 고딕"/>
+                <a:sym typeface="무궁화 고딕"/>
               </a:rPr>
               <a:t>고양이</a:t>
             </a:r>
@@ -4745,8 +4737,8 @@
         </p:nvSpPr>
         <p:spPr>
           <a:xfrm rot="0">
-            <a:off x="3238925" y="3349845"/>
-            <a:ext cx="11810151" cy="3514725"/>
+            <a:off x="3238925" y="3807045"/>
+            <a:ext cx="11810151" cy="3057525"/>
           </a:xfrm>
           <a:prstGeom prst="rect">
             <a:avLst/>
@@ -4768,10 +4760,10 @@
                 <a:solidFill>
                   <a:srgbClr val="000000"/>
                 </a:solidFill>
-                <a:latin typeface="Jua"/>
-                <a:ea typeface="Jua"/>
-                <a:cs typeface="Jua"/>
-                <a:sym typeface="Jua"/>
+                <a:latin typeface="무궁화 고딕"/>
+                <a:ea typeface="무궁화 고딕"/>
+                <a:cs typeface="무궁화 고딕"/>
+                <a:sym typeface="무궁화 고딕"/>
               </a:rPr>
               <a:t>바다</a:t>
             </a:r>
@@ -4868,8 +4860,8 @@
         </p:nvSpPr>
         <p:spPr>
           <a:xfrm rot="0">
-            <a:off x="3238925" y="3349845"/>
-            <a:ext cx="11810151" cy="3514725"/>
+            <a:off x="3238925" y="3807045"/>
+            <a:ext cx="11810151" cy="3057525"/>
           </a:xfrm>
           <a:prstGeom prst="rect">
             <a:avLst/>
@@ -4891,10 +4883,10 @@
                 <a:solidFill>
                   <a:srgbClr val="000000"/>
                 </a:solidFill>
-                <a:latin typeface="Jua"/>
-                <a:ea typeface="Jua"/>
-                <a:cs typeface="Jua"/>
-                <a:sym typeface="Jua"/>
+                <a:latin typeface="무궁화 고딕"/>
+                <a:ea typeface="무궁화 고딕"/>
+                <a:cs typeface="무궁화 고딕"/>
+                <a:sym typeface="무궁화 고딕"/>
               </a:rPr>
               <a:t>축구</a:t>
             </a:r>
@@ -4991,8 +4983,8 @@
         </p:nvSpPr>
         <p:spPr>
           <a:xfrm rot="0">
-            <a:off x="3238925" y="3349845"/>
-            <a:ext cx="11810151" cy="3514725"/>
+            <a:off x="3238925" y="3807045"/>
+            <a:ext cx="11810151" cy="3057525"/>
           </a:xfrm>
           <a:prstGeom prst="rect">
             <a:avLst/>
@@ -5014,10 +5006,10 @@
                 <a:solidFill>
                   <a:srgbClr val="000000"/>
                 </a:solidFill>
-                <a:latin typeface="Jua"/>
-                <a:ea typeface="Jua"/>
-                <a:cs typeface="Jua"/>
-                <a:sym typeface="Jua"/>
+                <a:latin typeface="무궁화 고딕"/>
+                <a:ea typeface="무궁화 고딕"/>
+                <a:cs typeface="무궁화 고딕"/>
+                <a:sym typeface="무궁화 고딕"/>
               </a:rPr>
               <a:t>학교</a:t>
             </a:r>
@@ -5114,8 +5106,8 @@
         </p:nvSpPr>
         <p:spPr>
           <a:xfrm rot="0">
-            <a:off x="3238925" y="3349845"/>
-            <a:ext cx="11810151" cy="3514725"/>
+            <a:off x="3238925" y="3807045"/>
+            <a:ext cx="11810151" cy="3057525"/>
           </a:xfrm>
           <a:prstGeom prst="rect">
             <a:avLst/>
@@ -5137,10 +5129,10 @@
                 <a:solidFill>
                   <a:srgbClr val="000000"/>
                 </a:solidFill>
-                <a:latin typeface="Jua"/>
-                <a:ea typeface="Jua"/>
-                <a:cs typeface="Jua"/>
-                <a:sym typeface="Jua"/>
+                <a:latin typeface="무궁화 고딕"/>
+                <a:ea typeface="무궁화 고딕"/>
+                <a:cs typeface="무궁화 고딕"/>
+                <a:sym typeface="무궁화 고딕"/>
               </a:rPr>
               <a:t>돈</a:t>
             </a:r>
@@ -5237,8 +5229,8 @@
         </p:nvSpPr>
         <p:spPr>
           <a:xfrm rot="0">
-            <a:off x="3238925" y="3349845"/>
-            <a:ext cx="11810151" cy="3514725"/>
+            <a:off x="3238925" y="3807045"/>
+            <a:ext cx="11810151" cy="3057525"/>
           </a:xfrm>
           <a:prstGeom prst="rect">
             <a:avLst/>
@@ -5260,10 +5252,10 @@
                 <a:solidFill>
                   <a:srgbClr val="000000"/>
                 </a:solidFill>
-                <a:latin typeface="Jua"/>
-                <a:ea typeface="Jua"/>
-                <a:cs typeface="Jua"/>
-                <a:sym typeface="Jua"/>
+                <a:latin typeface="무궁화 고딕"/>
+                <a:ea typeface="무궁화 고딕"/>
+                <a:cs typeface="무궁화 고딕"/>
+                <a:sym typeface="무궁화 고딕"/>
               </a:rPr>
               <a:t>배달</a:t>
             </a:r>

</xml_diff>